<commit_message>
artifacts: tvist.api rebrand + live URL; commit PDF generators
</commit_message>
<xml_diff>
--- a/assets/Tvist-Executive-Summary.pptx
+++ b/assets/Tvist-Executive-Summary.pptx
@@ -1367,7 +1367,7 @@
                 <a:ea typeface="Calibri" pitchFamily="34" charset="-122"/>
                 <a:cs typeface="Calibri" pitchFamily="34" charset="-120"/>
               </a:rPr>
-              <a:t>.ai</a:t>
+              <a:t>.api</a:t>
             </a:r>
             <a:pPr algn="l" indent="0" marL="0">
               <a:buNone/>
@@ -3842,7 +3842,7 @@
                 <a:ea typeface="Calibri" pitchFamily="34" charset="-122"/>
                 <a:cs typeface="Calibri" pitchFamily="34" charset="-120"/>
               </a:rPr>
-              <a:t>Live dual-use API + site: 33 endpoints incl. legal taxonomy, x402, M2M, region-suggest + spectrum; jurisdiction globe + Nash 1–1/1–n/n–n visualizer; 647 tests green. DigiDoot as flagship use case.</a:t>
+              <a:t>Live dual-use API + site: 33 endpoints incl. legal taxonomy, x402, M2M, region-suggest + spectrum; jurisdiction globe + Nash 1–1/1–n/n–n visualizer; 647 tests green. DigiDoot as flagship use case. Live: tvist-api-mias-projects-667d1349.vercel.app</a:t>
             </a:r>
             <a:endParaRPr lang="en-US" sz="880" dirty="0"/>
           </a:p>
@@ -16613,7 +16613,7 @@
                 <a:ea typeface="Calibri" pitchFamily="34" charset="-122"/>
                 <a:cs typeface="Calibri" pitchFamily="34" charset="-120"/>
               </a:rPr>
-              <a:t>33 endpoints incl. region-suggest, jurisdiction globe + Nash visualizer on-site, one SKILL.md, 61 endpoint tests — 647 green total.
+              <a:t>33 endpoints incl. region-suggest, jurisdiction globe + Nash visualizer on-site, one SKILL.md, 61 endpoint tests — 647 green total. Live: tvist-api-mias-projects-667d1349.vercel.app
 </a:t>
             </a:r>
             <a:pPr indent="0" marL="0">

</xml_diff>